<commit_message>
List everything Op 12 needs to compile and describe its servos
The header now names the one library, what ships with the board package,
that FastLED is no longer needed, and which "ESP32 Dev Module" to pick. The
buttons are named for Switch, Xbox and PlayStation pads, and the servo
comment and slide say center-to-one-end rather than full travel.

Co-Authored-By: Claude Opus 5.5 <noreply@anthropic.com>
</commit_message>
<xml_diff>
--- a/ground-vehicle/docs/courses/advanced/l2_motors_and_ramping.pptx
+++ b/ground-vehicle/docs/courses/advanced/l2_motors_and_ramping.pptx
@@ -11036,7 +11036,7 @@
         <p:spPr>
           <a:xfrm>
             <a:off x="502920" y="1188720"/>
-            <a:ext cx="4839335" cy="457200"/>
+            <a:ext cx="4669028" cy="457200"/>
           </a:xfrm>
           <a:prstGeom prst="rect">
             <a:avLst/>
@@ -11084,7 +11084,7 @@
         <p:spPr>
           <a:xfrm>
             <a:off x="502920" y="1700784"/>
-            <a:ext cx="4839335" cy="4562856"/>
+            <a:ext cx="4669028" cy="4562856"/>
           </a:xfrm>
           <a:prstGeom prst="rect">
             <a:avLst/>
@@ -11104,15 +11104,15 @@
               <a:spcAft>
                 <a:spcPts val="800"/>
               </a:spcAft>
-              <a:defRPr sz="1900" b="0">
-                <a:solidFill>
-                  <a:srgbClr val="222222"/>
-                </a:solidFill>
-                <a:latin typeface="Calibri"/>
-              </a:defRPr>
-            </a:pPr>
-            <a:r>
-              <a:rPr sz="1900" b="0">
+              <a:defRPr sz="1800" b="0">
+                <a:solidFill>
+                  <a:srgbClr val="222222"/>
+                </a:solidFill>
+                <a:latin typeface="Calibri"/>
+              </a:defRPr>
+            </a:pPr>
+            <a:r>
+              <a:rPr sz="1800" b="0">
                 <a:solidFill>
                   <a:srgbClr val="222222"/>
                 </a:solidFill>
@@ -11129,15 +11129,15 @@
               <a:spcAft>
                 <a:spcPts val="800"/>
               </a:spcAft>
-              <a:defRPr sz="1900" b="0">
-                <a:solidFill>
-                  <a:srgbClr val="222222"/>
-                </a:solidFill>
-                <a:latin typeface="Calibri"/>
-              </a:defRPr>
-            </a:pPr>
-            <a:r>
-              <a:rPr sz="1900" b="0">
+              <a:defRPr sz="1800" b="0">
+                <a:solidFill>
+                  <a:srgbClr val="222222"/>
+                </a:solidFill>
+                <a:latin typeface="Calibri"/>
+              </a:defRPr>
+            </a:pPr>
+            <a:r>
+              <a:rPr sz="1800" b="0">
                 <a:solidFill>
                   <a:srgbClr val="222222"/>
                 </a:solidFill>
@@ -11154,7 +11154,7 @@
               <a:spcAft>
                 <a:spcPts val="800"/>
               </a:spcAft>
-              <a:defRPr sz="950" b="0">
+              <a:defRPr sz="900" b="0">
                 <a:solidFill>
                   <a:srgbClr val="222222"/>
                 </a:solidFill>
@@ -11170,15 +11170,15 @@
               <a:spcAft>
                 <a:spcPts val="800"/>
               </a:spcAft>
-              <a:defRPr sz="1900" b="0">
-                <a:solidFill>
-                  <a:srgbClr val="222222"/>
-                </a:solidFill>
-                <a:latin typeface="Calibri"/>
-              </a:defRPr>
-            </a:pPr>
-            <a:r>
-              <a:rPr sz="1900" b="0">
+              <a:defRPr sz="1800" b="0">
+                <a:solidFill>
+                  <a:srgbClr val="222222"/>
+                </a:solidFill>
+                <a:latin typeface="Calibri"/>
+              </a:defRPr>
+            </a:pPr>
+            <a:r>
+              <a:rPr sz="1800" b="0">
                 <a:solidFill>
                   <a:srgbClr val="222222"/>
                 </a:solidFill>
@@ -11195,7 +11195,7 @@
               <a:spcAft>
                 <a:spcPts val="800"/>
               </a:spcAft>
-              <a:defRPr sz="950" b="0">
+              <a:defRPr sz="900" b="0">
                 <a:solidFill>
                   <a:srgbClr val="222222"/>
                 </a:solidFill>
@@ -11211,15 +11211,15 @@
               <a:spcAft>
                 <a:spcPts val="800"/>
               </a:spcAft>
-              <a:defRPr sz="1900" b="0">
-                <a:solidFill>
-                  <a:srgbClr val="222222"/>
-                </a:solidFill>
-                <a:latin typeface="Calibri"/>
-              </a:defRPr>
-            </a:pPr>
-            <a:r>
-              <a:rPr sz="1900" b="0">
+              <a:defRPr sz="1800" b="0">
+                <a:solidFill>
+                  <a:srgbClr val="222222"/>
+                </a:solidFill>
+                <a:latin typeface="Calibri"/>
+              </a:defRPr>
+            </a:pPr>
+            <a:r>
+              <a:rPr sz="1800" b="0">
                 <a:solidFill>
                   <a:srgbClr val="222222"/>
                 </a:solidFill>
@@ -11238,8 +11238,8 @@
         </p:nvSpPr>
         <p:spPr>
           <a:xfrm>
-            <a:off x="5799455" y="1188720"/>
-            <a:ext cx="5889320" cy="457200"/>
+            <a:off x="5629148" y="1188720"/>
+            <a:ext cx="6059627" cy="457200"/>
           </a:xfrm>
           <a:prstGeom prst="rect">
             <a:avLst/>
@@ -11286,8 +11286,8 @@
         </p:nvSpPr>
         <p:spPr>
           <a:xfrm>
-            <a:off x="5799455" y="1700784"/>
-            <a:ext cx="5889320" cy="4562856"/>
+            <a:off x="5629148" y="1700784"/>
+            <a:ext cx="6059627" cy="4562856"/>
           </a:xfrm>
           <a:prstGeom prst="rect">
             <a:avLst/>
@@ -11321,7 +11321,7 @@
                 </a:solidFill>
                 <a:latin typeface="Calibri"/>
               </a:rPr>
-              <a:t>Each servo owns one DIRECTION of the stick and sweeps its full travel across half the range:</a:t>
+              <a:t>Each servo owns one DIRECTION of the stick, and pushing that way moves it from center to one end, about 90 degrees:</a:t>
             </a:r>
           </a:p>
           <a:p>

</xml_diff>